<commit_message>
Fix text wrapping and overflow in HACHINOS deck
Co-Authored-By: Claude Opus 5.5 <noreply@anthropic.com>
Claude-Session: https://claude.ai/code/session_019eoJumTmTD33P2avudR6mS
</commit_message>
<xml_diff>
--- a/canva/hachinos/HACHINOS_presentation.pptx
+++ b/canva/hachinos/HACHINOS_presentation.pptx
@@ -10947,8 +10947,8 @@
         </p:nvSpPr>
         <p:spPr>
           <a:xfrm>
-            <a:off x="8823960" y="2514600"/>
-            <a:ext cx="2544775" cy="777240"/>
+            <a:off x="8823960" y="2560320"/>
+            <a:ext cx="2636215" cy="685800"/>
           </a:xfrm>
           <a:prstGeom prst="rect">
             <a:avLst/>
@@ -10964,7 +10964,7 @@
               <a:buNone/>
             </a:pPr>
             <a:r>
-              <a:rPr lang="en-US" sz="4400" b="1" dirty="0">
+              <a:rPr lang="en-US" sz="3200" b="1" dirty="0">
                 <a:solidFill>
                   <a:srgbClr val="FFD400"/>
                 </a:solidFill>
@@ -10978,7 +10978,7 @@
               <a:buNone/>
             </a:pPr>
             <a:r>
-              <a:rPr lang="en-US" sz="1400" dirty="0">
+              <a:rPr lang="en-US" sz="1300" dirty="0">
                 <a:solidFill>
                   <a:srgbClr val="FFFFFF"/>
                 </a:solidFill>
@@ -10988,7 +10988,7 @@
               </a:rPr>
               <a:t> 円／月</a:t>
             </a:r>
-            <a:endParaRPr lang="en-US" sz="4400" dirty="0"/>
+            <a:endParaRPr lang="en-US" sz="3200" dirty="0"/>
           </a:p>
         </p:txBody>
       </p:sp>
@@ -14252,7 +14252,7 @@
         </p:nvSpPr>
         <p:spPr>
           <a:xfrm>
-            <a:off x="457200" y="5120640"/>
+            <a:off x="9509760" y="5120640"/>
             <a:ext cx="822960" cy="712683"/>
           </a:xfrm>
           <a:prstGeom prst="hexagon">
@@ -14277,7 +14277,7 @@
         </p:nvSpPr>
         <p:spPr>
           <a:xfrm>
-            <a:off x="1097280" y="5669280"/>
+            <a:off x="8686800" y="5760720"/>
             <a:ext cx="640080" cy="554309"/>
           </a:xfrm>
           <a:prstGeom prst="hexagon">
@@ -14810,8 +14810,8 @@
         </p:nvSpPr>
         <p:spPr>
           <a:xfrm>
-            <a:off x="678028" y="3794760"/>
-            <a:ext cx="1874520" cy="914400"/>
+            <a:off x="659740" y="3703320"/>
+            <a:ext cx="1911096" cy="1097280"/>
           </a:xfrm>
           <a:prstGeom prst="rect">
             <a:avLst/>
@@ -14923,8 +14923,8 @@
         </p:nvSpPr>
         <p:spPr>
           <a:xfrm>
-            <a:off x="2918308" y="3794760"/>
-            <a:ext cx="1874520" cy="914400"/>
+            <a:off x="2900020" y="3703320"/>
+            <a:ext cx="1911096" cy="1097280"/>
           </a:xfrm>
           <a:prstGeom prst="rect">
             <a:avLst/>
@@ -14951,7 +14951,27 @@
                 <a:ea typeface="Noto Sans JP" pitchFamily="34" charset="-122"/>
                 <a:cs typeface="Noto Sans JP" pitchFamily="34" charset="-120"/>
               </a:rPr>
-              <a:t>どんなお客様が来ているか</a:t>
+              <a:t>どんなお客様が</a:t>
+            </a:r>
+            <a:endParaRPr lang="en-US" sz="1300" dirty="0"/>
+          </a:p>
+          <a:p>
+            <a:pPr algn="ctr" indent="0" marL="0">
+              <a:lnSpc>
+                <a:spcPct val="130000"/>
+              </a:lnSpc>
+              <a:buNone/>
+            </a:pPr>
+            <a:r>
+              <a:rPr lang="en-US" sz="1300" b="1" dirty="0">
+                <a:solidFill>
+                  <a:srgbClr val="222222"/>
+                </a:solidFill>
+                <a:latin typeface="Noto Sans JP" pitchFamily="34" charset="0"/>
+                <a:ea typeface="Noto Sans JP" pitchFamily="34" charset="-122"/>
+                <a:cs typeface="Noto Sans JP" pitchFamily="34" charset="-120"/>
+              </a:rPr>
+              <a:t>来ているか</a:t>
             </a:r>
             <a:endParaRPr lang="en-US" sz="1300" dirty="0"/>
           </a:p>
@@ -15036,8 +15056,8 @@
         </p:nvSpPr>
         <p:spPr>
           <a:xfrm>
-            <a:off x="5158588" y="3794760"/>
-            <a:ext cx="1874520" cy="914400"/>
+            <a:off x="5140300" y="3703320"/>
+            <a:ext cx="1911096" cy="1097280"/>
           </a:xfrm>
           <a:prstGeom prst="rect">
             <a:avLst/>
@@ -15064,7 +15084,7 @@
                 <a:ea typeface="Noto Sans JP" pitchFamily="34" charset="-122"/>
                 <a:cs typeface="Noto Sans JP" pitchFamily="34" charset="-120"/>
               </a:rPr>
-              <a:t>売場やレイアウトの効果を</a:t>
+              <a:t>売場やレイアウトの</a:t>
             </a:r>
             <a:endParaRPr lang="en-US" sz="1300" dirty="0"/>
           </a:p>
@@ -15084,7 +15104,7 @@
                 <a:ea typeface="Noto Sans JP" pitchFamily="34" charset="-122"/>
                 <a:cs typeface="Noto Sans JP" pitchFamily="34" charset="-120"/>
               </a:rPr>
-              <a:t>検証できない</a:t>
+              <a:t>効果を検証できない</a:t>
             </a:r>
             <a:endParaRPr lang="en-US" sz="1300" dirty="0"/>
           </a:p>
@@ -15149,8 +15169,8 @@
         </p:nvSpPr>
         <p:spPr>
           <a:xfrm>
-            <a:off x="7398868" y="3794760"/>
-            <a:ext cx="1874520" cy="914400"/>
+            <a:off x="7380580" y="3703320"/>
+            <a:ext cx="1911096" cy="1097280"/>
           </a:xfrm>
           <a:prstGeom prst="rect">
             <a:avLst/>
@@ -15197,7 +15217,27 @@
                 <a:ea typeface="Noto Sans JP" pitchFamily="34" charset="-122"/>
                 <a:cs typeface="Noto Sans JP" pitchFamily="34" charset="-120"/>
               </a:rPr>
-              <a:t>気づくのが遅れる</a:t>
+              <a:t>気づくのが</a:t>
+            </a:r>
+            <a:endParaRPr lang="en-US" sz="1300" dirty="0"/>
+          </a:p>
+          <a:p>
+            <a:pPr algn="ctr" indent="0" marL="0">
+              <a:lnSpc>
+                <a:spcPct val="130000"/>
+              </a:lnSpc>
+              <a:buNone/>
+            </a:pPr>
+            <a:r>
+              <a:rPr lang="en-US" sz="1300" b="1" dirty="0">
+                <a:solidFill>
+                  <a:srgbClr val="222222"/>
+                </a:solidFill>
+                <a:latin typeface="Noto Sans JP" pitchFamily="34" charset="0"/>
+                <a:ea typeface="Noto Sans JP" pitchFamily="34" charset="-122"/>
+                <a:cs typeface="Noto Sans JP" pitchFamily="34" charset="-120"/>
+              </a:rPr>
+              <a:t>遅れる</a:t>
             </a:r>
             <a:endParaRPr lang="en-US" sz="1300" dirty="0"/>
           </a:p>
@@ -15262,8 +15302,8 @@
         </p:nvSpPr>
         <p:spPr>
           <a:xfrm>
-            <a:off x="9639148" y="3794760"/>
-            <a:ext cx="1874520" cy="914400"/>
+            <a:off x="9620860" y="3703320"/>
+            <a:ext cx="1911096" cy="1097280"/>
           </a:xfrm>
           <a:prstGeom prst="rect">
             <a:avLst/>
@@ -15318,27 +15358,7 @@
       </p:sp>
       <p:sp>
         <p:nvSpPr>
-          <p:cNvPr id="22" name="Shape 14"/>
-          <p:cNvSpPr/>
-          <p:nvPr/>
-        </p:nvSpPr>
-        <p:spPr>
-          <a:xfrm>
-            <a:off x="4224528" y="5806440"/>
-            <a:ext cx="3749040" cy="201168"/>
-          </a:xfrm>
-          <a:prstGeom prst="rect">
-            <a:avLst/>
-          </a:prstGeom>
-          <a:solidFill>
-            <a:srgbClr val="FFD400"/>
-          </a:solidFill>
-          <a:ln/>
-        </p:spPr>
-      </p:sp>
-      <p:sp>
-        <p:nvSpPr>
-          <p:cNvPr id="23" name="Text 15"/>
+          <p:cNvPr id="22" name="Text 14"/>
           <p:cNvSpPr txBox="1"/>
           <p:nvPr/>
         </p:nvSpPr>
@@ -15379,6 +15399,9 @@
                 <a:solidFill>
                   <a:srgbClr val="111111"/>
                 </a:solidFill>
+                <a:highlight>
+                  <a:srgbClr val="FFD400"/>
+                </a:highlight>
                 <a:latin typeface="Noto Sans JP" pitchFamily="34" charset="0"/>
                 <a:ea typeface="Noto Sans JP" pitchFamily="34" charset="-122"/>
                 <a:cs typeface="Noto Sans JP" pitchFamily="34" charset="-120"/>
@@ -16728,8 +16751,8 @@
         </p:nvSpPr>
         <p:spPr>
           <a:xfrm>
-            <a:off x="582016" y="3840480"/>
-            <a:ext cx="1883664" cy="685800"/>
+            <a:off x="527152" y="3840480"/>
+            <a:ext cx="1993392" cy="685800"/>
           </a:xfrm>
           <a:prstGeom prst="rect">
             <a:avLst/>
@@ -16745,7 +16768,7 @@
               <a:buNone/>
             </a:pPr>
             <a:r>
-              <a:rPr lang="en-US" sz="1500" b="1" dirty="0">
+              <a:rPr lang="en-US" sz="1350" b="1" dirty="0">
                 <a:solidFill>
                   <a:srgbClr val="111111"/>
                 </a:solidFill>
@@ -16755,7 +16778,7 @@
               </a:rPr>
               <a:t>カメラの買い替え不要</a:t>
             </a:r>
-            <a:endParaRPr lang="en-US" sz="1500" dirty="0"/>
+            <a:endParaRPr lang="en-US" sz="1350" dirty="0"/>
           </a:p>
         </p:txBody>
       </p:sp>
@@ -16855,8 +16878,8 @@
         </p:nvSpPr>
         <p:spPr>
           <a:xfrm>
-            <a:off x="2868016" y="3840480"/>
-            <a:ext cx="1883664" cy="685800"/>
+            <a:off x="2813152" y="3840480"/>
+            <a:ext cx="1993392" cy="685800"/>
           </a:xfrm>
           <a:prstGeom prst="rect">
             <a:avLst/>
@@ -16872,7 +16895,7 @@
               <a:buNone/>
             </a:pPr>
             <a:r>
-              <a:rPr lang="en-US" sz="1500" b="1" dirty="0">
+              <a:rPr lang="en-US" sz="1350" b="1" dirty="0">
                 <a:solidFill>
                   <a:srgbClr val="111111"/>
                 </a:solidFill>
@@ -16882,7 +16905,7 @@
               </a:rPr>
               <a:t>映像は施設内で処理</a:t>
             </a:r>
-            <a:endParaRPr lang="en-US" sz="1500" dirty="0"/>
+            <a:endParaRPr lang="en-US" sz="1350" dirty="0"/>
           </a:p>
         </p:txBody>
       </p:sp>
@@ -16982,8 +17005,8 @@
         </p:nvSpPr>
         <p:spPr>
           <a:xfrm>
-            <a:off x="5154016" y="3840480"/>
-            <a:ext cx="1883664" cy="685800"/>
+            <a:off x="5099152" y="3840480"/>
+            <a:ext cx="1993392" cy="685800"/>
           </a:xfrm>
           <a:prstGeom prst="rect">
             <a:avLst/>
@@ -16999,7 +17022,7 @@
               <a:buNone/>
             </a:pPr>
             <a:r>
-              <a:rPr lang="en-US" sz="1500" b="1" dirty="0">
+              <a:rPr lang="en-US" sz="1350" b="1" dirty="0">
                 <a:solidFill>
                   <a:srgbClr val="111111"/>
                 </a:solidFill>
@@ -17009,7 +17032,7 @@
               </a:rPr>
               <a:t>小さく始めて広げられる</a:t>
             </a:r>
-            <a:endParaRPr lang="en-US" sz="1500" dirty="0"/>
+            <a:endParaRPr lang="en-US" sz="1350" dirty="0"/>
           </a:p>
         </p:txBody>
       </p:sp>
@@ -17109,8 +17132,8 @@
         </p:nvSpPr>
         <p:spPr>
           <a:xfrm>
-            <a:off x="7440016" y="3840480"/>
-            <a:ext cx="1883664" cy="685800"/>
+            <a:off x="7385152" y="3840480"/>
+            <a:ext cx="1993392" cy="685800"/>
           </a:xfrm>
           <a:prstGeom prst="rect">
             <a:avLst/>
@@ -17126,7 +17149,7 @@
               <a:buNone/>
             </a:pPr>
             <a:r>
-              <a:rPr lang="en-US" sz="1500" b="1" dirty="0">
+              <a:rPr lang="en-US" sz="1350" b="1" dirty="0">
                 <a:solidFill>
                   <a:srgbClr val="111111"/>
                 </a:solidFill>
@@ -17136,7 +17159,7 @@
               </a:rPr>
               <a:t>データで売上改善</a:t>
             </a:r>
-            <a:endParaRPr lang="en-US" sz="1500" dirty="0"/>
+            <a:endParaRPr lang="en-US" sz="1350" dirty="0"/>
           </a:p>
         </p:txBody>
       </p:sp>
@@ -17236,8 +17259,8 @@
         </p:nvSpPr>
         <p:spPr>
           <a:xfrm>
-            <a:off x="9726016" y="3840480"/>
-            <a:ext cx="1883664" cy="685800"/>
+            <a:off x="9671152" y="3840480"/>
+            <a:ext cx="1993392" cy="685800"/>
           </a:xfrm>
           <a:prstGeom prst="rect">
             <a:avLst/>
@@ -17253,7 +17276,7 @@
               <a:buNone/>
             </a:pPr>
             <a:r>
-              <a:rPr lang="en-US" sz="1500" b="1" dirty="0">
+              <a:rPr lang="en-US" sz="1350" b="1" dirty="0">
                 <a:solidFill>
                   <a:srgbClr val="111111"/>
                 </a:solidFill>
@@ -17263,7 +17286,7 @@
               </a:rPr>
               <a:t>見守り・省人化</a:t>
             </a:r>
-            <a:endParaRPr lang="en-US" sz="1500" dirty="0"/>
+            <a:endParaRPr lang="en-US" sz="1350" dirty="0"/>
           </a:p>
         </p:txBody>
       </p:sp>
@@ -17567,54 +17590,7 @@
       </p:sp>
       <p:sp>
         <p:nvSpPr>
-          <p:cNvPr id="9" name="Shape 5"/>
-          <p:cNvSpPr/>
-          <p:nvPr/>
-        </p:nvSpPr>
-        <p:spPr>
-          <a:xfrm>
-            <a:off x="10424160" y="5120640"/>
-            <a:ext cx="1005840" cy="871057"/>
-          </a:xfrm>
-          <a:prstGeom prst="hexagon">
-            <a:avLst/>
-          </a:prstGeom>
-          <a:ln w="38100">
-            <a:solidFill>
-              <a:srgbClr val="FFD400"/>
-            </a:solidFill>
-            <a:prstDash val="solid"/>
-          </a:ln>
-        </p:spPr>
-      </p:sp>
-      <p:sp>
-        <p:nvSpPr>
-          <p:cNvPr id="10" name="Shape 6"/>
-          <p:cNvSpPr/>
-          <p:nvPr/>
-        </p:nvSpPr>
-        <p:spPr>
-          <a:xfrm>
-            <a:off x="11064240" y="5806440"/>
-            <a:ext cx="685800" cy="593903"/>
-          </a:xfrm>
-          <a:prstGeom prst="hexagon">
-            <a:avLst/>
-          </a:prstGeom>
-          <a:solidFill>
-            <a:srgbClr val="FFD400"/>
-          </a:solidFill>
-          <a:ln w="12700">
-            <a:solidFill>
-              <a:srgbClr val="FFD400"/>
-            </a:solidFill>
-            <a:prstDash val="solid"/>
-          </a:ln>
-        </p:spPr>
-      </p:sp>
-      <p:sp>
-        <p:nvSpPr>
-          <p:cNvPr id="11" name="Text 7"/>
+          <p:cNvPr id="9" name="Text 5"/>
           <p:cNvSpPr txBox="1"/>
           <p:nvPr/>
         </p:nvSpPr>
@@ -17676,7 +17652,7 @@
       </p:sp>
       <p:sp>
         <p:nvSpPr>
-          <p:cNvPr id="12" name="Text 8"/>
+          <p:cNvPr id="10" name="Text 6"/>
           <p:cNvSpPr txBox="1"/>
           <p:nvPr/>
         </p:nvSpPr>
@@ -17718,7 +17694,7 @@
       </p:sp>
       <p:sp>
         <p:nvSpPr>
-          <p:cNvPr id="13" name="Shape 9"/>
+          <p:cNvPr id="11" name="Shape 7"/>
           <p:cNvSpPr/>
           <p:nvPr/>
         </p:nvSpPr>
@@ -17738,7 +17714,7 @@
       </p:sp>
       <p:sp>
         <p:nvSpPr>
-          <p:cNvPr id="14" name="Text 10"/>
+          <p:cNvPr id="12" name="Text 8"/>
           <p:cNvSpPr txBox="1"/>
           <p:nvPr/>
         </p:nvSpPr>
@@ -17777,14 +17753,14 @@
       </p:sp>
       <p:sp>
         <p:nvSpPr>
-          <p:cNvPr id="15" name="Text 11"/>
+          <p:cNvPr id="13" name="Text 9"/>
           <p:cNvSpPr txBox="1"/>
           <p:nvPr/>
         </p:nvSpPr>
         <p:spPr>
           <a:xfrm>
             <a:off x="6812280" y="4663440"/>
-            <a:ext cx="4846320" cy="329184"/>
+            <a:ext cx="5029200" cy="329184"/>
           </a:xfrm>
           <a:prstGeom prst="rect">
             <a:avLst/>
@@ -17800,7 +17776,7 @@
               <a:buNone/>
             </a:pPr>
             <a:r>
-              <a:rPr lang="en-US" sz="1400" b="1" dirty="0">
+              <a:rPr lang="en-US" sz="1300" b="1" dirty="0">
                 <a:solidFill>
                   <a:srgbClr val="111111"/>
                 </a:solidFill>
@@ -17810,13 +17786,13 @@
               </a:rPr>
               <a:t>既存カメラをそのまま利用（対応可否は事前ヒアリングで確認）</a:t>
             </a:r>
-            <a:endParaRPr lang="en-US" sz="1400" dirty="0"/>
-          </a:p>
-        </p:txBody>
-      </p:sp>
-      <p:sp>
-        <p:nvSpPr>
-          <p:cNvPr id="16" name="Shape 12"/>
+            <a:endParaRPr lang="en-US" sz="1300" dirty="0"/>
+          </a:p>
+        </p:txBody>
+      </p:sp>
+      <p:sp>
+        <p:nvSpPr>
+          <p:cNvPr id="14" name="Shape 10"/>
           <p:cNvSpPr/>
           <p:nvPr/>
         </p:nvSpPr>
@@ -17836,7 +17812,7 @@
       </p:sp>
       <p:sp>
         <p:nvSpPr>
-          <p:cNvPr id="17" name="Text 13"/>
+          <p:cNvPr id="15" name="Text 11"/>
           <p:cNvSpPr txBox="1"/>
           <p:nvPr/>
         </p:nvSpPr>
@@ -17875,14 +17851,14 @@
       </p:sp>
       <p:sp>
         <p:nvSpPr>
-          <p:cNvPr id="18" name="Text 14"/>
+          <p:cNvPr id="16" name="Text 12"/>
           <p:cNvSpPr txBox="1"/>
           <p:nvPr/>
         </p:nvSpPr>
         <p:spPr>
           <a:xfrm>
             <a:off x="6812280" y="5120640"/>
-            <a:ext cx="4846320" cy="329184"/>
+            <a:ext cx="5029200" cy="329184"/>
           </a:xfrm>
           <a:prstGeom prst="rect">
             <a:avLst/>
@@ -17898,7 +17874,7 @@
               <a:buNone/>
             </a:pPr>
             <a:r>
-              <a:rPr lang="en-US" sz="1400" b="1" dirty="0">
+              <a:rPr lang="en-US" sz="1300" b="1" dirty="0">
                 <a:solidFill>
                   <a:srgbClr val="111111"/>
                 </a:solidFill>
@@ -17908,13 +17884,13 @@
               </a:rPr>
               <a:t>映像は施設内の本体で処理</a:t>
             </a:r>
-            <a:endParaRPr lang="en-US" sz="1400" dirty="0"/>
-          </a:p>
-        </p:txBody>
-      </p:sp>
-      <p:sp>
-        <p:nvSpPr>
-          <p:cNvPr id="19" name="Shape 15"/>
+            <a:endParaRPr lang="en-US" sz="1300" dirty="0"/>
+          </a:p>
+        </p:txBody>
+      </p:sp>
+      <p:sp>
+        <p:nvSpPr>
+          <p:cNvPr id="17" name="Shape 13"/>
           <p:cNvSpPr/>
           <p:nvPr/>
         </p:nvSpPr>
@@ -17934,7 +17910,7 @@
       </p:sp>
       <p:sp>
         <p:nvSpPr>
-          <p:cNvPr id="20" name="Text 16"/>
+          <p:cNvPr id="18" name="Text 14"/>
           <p:cNvSpPr txBox="1"/>
           <p:nvPr/>
         </p:nvSpPr>
@@ -17973,14 +17949,14 @@
       </p:sp>
       <p:sp>
         <p:nvSpPr>
-          <p:cNvPr id="21" name="Text 17"/>
+          <p:cNvPr id="19" name="Text 15"/>
           <p:cNvSpPr txBox="1"/>
           <p:nvPr/>
         </p:nvSpPr>
         <p:spPr>
           <a:xfrm>
             <a:off x="6812280" y="5577840"/>
-            <a:ext cx="4846320" cy="329184"/>
+            <a:ext cx="5029200" cy="329184"/>
           </a:xfrm>
           <a:prstGeom prst="rect">
             <a:avLst/>
@@ -17996,7 +17972,7 @@
               <a:buNone/>
             </a:pPr>
             <a:r>
-              <a:rPr lang="en-US" sz="1400" b="1" dirty="0">
+              <a:rPr lang="en-US" sz="1300" b="1" dirty="0">
                 <a:solidFill>
                   <a:srgbClr val="111111"/>
                 </a:solidFill>
@@ -18006,7 +17982,7 @@
               </a:rPr>
               <a:t>ネット回線が切れても本体はローカルで稼働</a:t>
             </a:r>
-            <a:endParaRPr lang="en-US" sz="1400" dirty="0"/>
+            <a:endParaRPr lang="en-US" sz="1300" dirty="0"/>
           </a:p>
         </p:txBody>
       </p:sp>
@@ -19154,7 +19130,24 @@
                 <a:ea typeface="Noto Sans JP" pitchFamily="34" charset="-122"/>
                 <a:cs typeface="Noto Sans JP" pitchFamily="34" charset="-120"/>
               </a:rPr>
-              <a:t>属性分析／リピート検知</a:t>
+              <a:t>属性分析／</a:t>
+            </a:r>
+            <a:endParaRPr lang="en-US" sz="1500" dirty="0"/>
+          </a:p>
+          <a:p>
+            <a:pPr indent="0" marL="0">
+              <a:buNone/>
+            </a:pPr>
+            <a:r>
+              <a:rPr lang="en-US" sz="1500" b="1" dirty="0">
+                <a:solidFill>
+                  <a:srgbClr val="111111"/>
+                </a:solidFill>
+                <a:latin typeface="Noto Sans JP" pitchFamily="34" charset="0"/>
+                <a:ea typeface="Noto Sans JP" pitchFamily="34" charset="-122"/>
+                <a:cs typeface="Noto Sans JP" pitchFamily="34" charset="-120"/>
+              </a:rPr>
+              <a:t>リピート検知</a:t>
             </a:r>
             <a:endParaRPr lang="en-US" sz="1500" dirty="0"/>
           </a:p>
@@ -19452,7 +19445,24 @@
                 <a:ea typeface="Noto Sans JP" pitchFamily="34" charset="-122"/>
                 <a:cs typeface="Noto Sans JP" pitchFamily="34" charset="-120"/>
               </a:rPr>
-              <a:t>通行量／人数カウント</a:t>
+              <a:t>通行量／</a:t>
+            </a:r>
+            <a:endParaRPr lang="en-US" sz="1500" dirty="0"/>
+          </a:p>
+          <a:p>
+            <a:pPr indent="0" marL="0">
+              <a:buNone/>
+            </a:pPr>
+            <a:r>
+              <a:rPr lang="en-US" sz="1500" b="1" dirty="0">
+                <a:solidFill>
+                  <a:srgbClr val="111111"/>
+                </a:solidFill>
+                <a:latin typeface="Noto Sans JP" pitchFamily="34" charset="0"/>
+                <a:ea typeface="Noto Sans JP" pitchFamily="34" charset="-122"/>
+                <a:cs typeface="Noto Sans JP" pitchFamily="34" charset="-120"/>
+              </a:rPr>
+              <a:t>人数カウント</a:t>
             </a:r>
             <a:endParaRPr lang="en-US" sz="1500" dirty="0"/>
           </a:p>
@@ -19601,7 +19611,24 @@
                 <a:ea typeface="Noto Sans JP" pitchFamily="34" charset="-122"/>
                 <a:cs typeface="Noto Sans JP" pitchFamily="34" charset="-120"/>
               </a:rPr>
-              <a:t>侵入／ラインクロス／エリア検知</a:t>
+              <a:t>侵入／ラインクロス／</a:t>
+            </a:r>
+            <a:endParaRPr lang="en-US" sz="1500" dirty="0"/>
+          </a:p>
+          <a:p>
+            <a:pPr indent="0" marL="0">
+              <a:buNone/>
+            </a:pPr>
+            <a:r>
+              <a:rPr lang="en-US" sz="1500" b="1" dirty="0">
+                <a:solidFill>
+                  <a:srgbClr val="111111"/>
+                </a:solidFill>
+                <a:latin typeface="Noto Sans JP" pitchFamily="34" charset="0"/>
+                <a:ea typeface="Noto Sans JP" pitchFamily="34" charset="-122"/>
+                <a:cs typeface="Noto Sans JP" pitchFamily="34" charset="-120"/>
+              </a:rPr>
+              <a:t>エリア検知</a:t>
             </a:r>
             <a:endParaRPr lang="en-US" sz="1500" dirty="0"/>
           </a:p>
@@ -19750,7 +19777,24 @@
                 <a:ea typeface="Noto Sans JP" pitchFamily="34" charset="-122"/>
                 <a:cs typeface="Noto Sans JP" pitchFamily="34" charset="-120"/>
               </a:rPr>
-              <a:t>転倒／タバコ／火災検知</a:t>
+              <a:t>転倒／タバコ／</a:t>
+            </a:r>
+            <a:endParaRPr lang="en-US" sz="1500" dirty="0"/>
+          </a:p>
+          <a:p>
+            <a:pPr indent="0" marL="0">
+              <a:buNone/>
+            </a:pPr>
+            <a:r>
+              <a:rPr lang="en-US" sz="1500" b="1" dirty="0">
+                <a:solidFill>
+                  <a:srgbClr val="111111"/>
+                </a:solidFill>
+                <a:latin typeface="Noto Sans JP" pitchFamily="34" charset="0"/>
+                <a:ea typeface="Noto Sans JP" pitchFamily="34" charset="-122"/>
+                <a:cs typeface="Noto Sans JP" pitchFamily="34" charset="-120"/>
+              </a:rPr>
+              <a:t>火災検知</a:t>
             </a:r>
             <a:endParaRPr lang="en-US" sz="1500" dirty="0"/>
           </a:p>
@@ -21658,8 +21702,8 @@
         </p:nvSpPr>
         <p:spPr>
           <a:xfrm>
-            <a:off x="700888" y="4434840"/>
-            <a:ext cx="1645920" cy="411480"/>
+            <a:off x="673456" y="4434840"/>
+            <a:ext cx="1737360" cy="411480"/>
           </a:xfrm>
           <a:prstGeom prst="rect">
             <a:avLst/>
@@ -21675,7 +21719,7 @@
               <a:buNone/>
             </a:pPr>
             <a:r>
-              <a:rPr lang="en-US" sz="1100" b="1" dirty="0">
+              <a:rPr lang="en-US" sz="1000" b="1" dirty="0">
                 <a:solidFill>
                   <a:srgbClr val="111111"/>
                 </a:solidFill>
@@ -21685,7 +21729,7 @@
               </a:rPr>
               <a:t>レジ配置の最適化</a:t>
             </a:r>
-            <a:endParaRPr lang="en-US" sz="1100" dirty="0"/>
+            <a:endParaRPr lang="en-US" sz="1000" dirty="0"/>
           </a:p>
         </p:txBody>
       </p:sp>
@@ -21719,8 +21763,8 @@
         </p:nvSpPr>
         <p:spPr>
           <a:xfrm>
-            <a:off x="700888" y="4965192"/>
-            <a:ext cx="1645920" cy="411480"/>
+            <a:off x="673456" y="4965192"/>
+            <a:ext cx="1737360" cy="411480"/>
           </a:xfrm>
           <a:prstGeom prst="rect">
             <a:avLst/>
@@ -21736,7 +21780,7 @@
               <a:buNone/>
             </a:pPr>
             <a:r>
-              <a:rPr lang="en-US" sz="1100" b="1" dirty="0">
+              <a:rPr lang="en-US" sz="1000" b="1" dirty="0">
                 <a:solidFill>
                   <a:srgbClr val="111111"/>
                 </a:solidFill>
@@ -21746,7 +21790,7 @@
               </a:rPr>
               <a:t>値引き・発注の判断材料</a:t>
             </a:r>
-            <a:endParaRPr lang="en-US" sz="1100" dirty="0"/>
+            <a:endParaRPr lang="en-US" sz="1000" dirty="0"/>
           </a:p>
         </p:txBody>
       </p:sp>
@@ -21780,8 +21824,8 @@
         </p:nvSpPr>
         <p:spPr>
           <a:xfrm>
-            <a:off x="700888" y="5495544"/>
-            <a:ext cx="1645920" cy="411480"/>
+            <a:off x="673456" y="5495544"/>
+            <a:ext cx="1737360" cy="411480"/>
           </a:xfrm>
           <a:prstGeom prst="rect">
             <a:avLst/>
@@ -21797,7 +21841,7 @@
               <a:buNone/>
             </a:pPr>
             <a:r>
-              <a:rPr lang="en-US" sz="1100" b="1" dirty="0">
+              <a:rPr lang="en-US" sz="1000" b="1" dirty="0">
                 <a:solidFill>
                   <a:srgbClr val="111111"/>
                 </a:solidFill>
@@ -21807,7 +21851,7 @@
               </a:rPr>
               <a:t>万引きなどのロス防止</a:t>
             </a:r>
-            <a:endParaRPr lang="en-US" sz="1100" dirty="0"/>
+            <a:endParaRPr lang="en-US" sz="1000" dirty="0"/>
           </a:p>
         </p:txBody>
       </p:sp>
@@ -21965,8 +22009,8 @@
         </p:nvSpPr>
         <p:spPr>
           <a:xfrm>
-            <a:off x="2986888" y="4434840"/>
-            <a:ext cx="1645920" cy="411480"/>
+            <a:off x="2959456" y="4434840"/>
+            <a:ext cx="1737360" cy="411480"/>
           </a:xfrm>
           <a:prstGeom prst="rect">
             <a:avLst/>
@@ -21982,7 +22026,7 @@
               <a:buNone/>
             </a:pPr>
             <a:r>
-              <a:rPr lang="en-US" sz="1100" b="1" dirty="0">
+              <a:rPr lang="en-US" sz="1000" b="1" dirty="0">
                 <a:solidFill>
                   <a:srgbClr val="111111"/>
                 </a:solidFill>
@@ -21992,7 +22036,7 @@
               </a:rPr>
               <a:t>片付け・案内の迅速化</a:t>
             </a:r>
-            <a:endParaRPr lang="en-US" sz="1100" dirty="0"/>
+            <a:endParaRPr lang="en-US" sz="1000" dirty="0"/>
           </a:p>
         </p:txBody>
       </p:sp>
@@ -22026,8 +22070,8 @@
         </p:nvSpPr>
         <p:spPr>
           <a:xfrm>
-            <a:off x="2986888" y="4965192"/>
-            <a:ext cx="1645920" cy="411480"/>
+            <a:off x="2959456" y="4965192"/>
+            <a:ext cx="1737360" cy="411480"/>
           </a:xfrm>
           <a:prstGeom prst="rect">
             <a:avLst/>
@@ -22043,7 +22087,7 @@
               <a:buNone/>
             </a:pPr>
             <a:r>
-              <a:rPr lang="en-US" sz="1100" b="1" dirty="0">
+              <a:rPr lang="en-US" sz="1000" b="1" dirty="0">
                 <a:solidFill>
                   <a:srgbClr val="111111"/>
                 </a:solidFill>
@@ -22053,7 +22097,7 @@
               </a:rPr>
               <a:t>追加注文のきっかけづくり</a:t>
             </a:r>
-            <a:endParaRPr lang="en-US" sz="1100" dirty="0"/>
+            <a:endParaRPr lang="en-US" sz="1000" dirty="0"/>
           </a:p>
         </p:txBody>
       </p:sp>
@@ -22087,8 +22131,8 @@
         </p:nvSpPr>
         <p:spPr>
           <a:xfrm>
-            <a:off x="2986888" y="5495544"/>
-            <a:ext cx="1645920" cy="411480"/>
+            <a:off x="2959456" y="5495544"/>
+            <a:ext cx="1737360" cy="411480"/>
           </a:xfrm>
           <a:prstGeom prst="rect">
             <a:avLst/>
@@ -22104,7 +22148,7 @@
               <a:buNone/>
             </a:pPr>
             <a:r>
-              <a:rPr lang="en-US" sz="1100" b="1" dirty="0">
+              <a:rPr lang="en-US" sz="1000" b="1" dirty="0">
                 <a:solidFill>
                   <a:srgbClr val="111111"/>
                 </a:solidFill>
@@ -22114,7 +22158,7 @@
               </a:rPr>
               <a:t>仕込み・人員配置の計画</a:t>
             </a:r>
-            <a:endParaRPr lang="en-US" sz="1100" dirty="0"/>
+            <a:endParaRPr lang="en-US" sz="1000" dirty="0"/>
           </a:p>
         </p:txBody>
       </p:sp>
@@ -22272,8 +22316,8 @@
         </p:nvSpPr>
         <p:spPr>
           <a:xfrm>
-            <a:off x="5272888" y="4434840"/>
-            <a:ext cx="1645920" cy="411480"/>
+            <a:off x="5245456" y="4434840"/>
+            <a:ext cx="1737360" cy="411480"/>
           </a:xfrm>
           <a:prstGeom prst="rect">
             <a:avLst/>
@@ -22289,7 +22333,7 @@
               <a:buNone/>
             </a:pPr>
             <a:r>
-              <a:rPr lang="en-US" sz="1100" b="1" dirty="0">
+              <a:rPr lang="en-US" sz="1000" b="1" dirty="0">
                 <a:solidFill>
                   <a:srgbClr val="111111"/>
                 </a:solidFill>
@@ -22299,7 +22343,7 @@
               </a:rPr>
               <a:t>回遊・立ち寄りの分析</a:t>
             </a:r>
-            <a:endParaRPr lang="en-US" sz="1100" dirty="0"/>
+            <a:endParaRPr lang="en-US" sz="1000" dirty="0"/>
           </a:p>
         </p:txBody>
       </p:sp>
@@ -22333,8 +22377,8 @@
         </p:nvSpPr>
         <p:spPr>
           <a:xfrm>
-            <a:off x="5272888" y="4965192"/>
-            <a:ext cx="1645920" cy="411480"/>
+            <a:off x="5245456" y="4965192"/>
+            <a:ext cx="1737360" cy="411480"/>
           </a:xfrm>
           <a:prstGeom prst="rect">
             <a:avLst/>
@@ -22350,7 +22394,7 @@
               <a:buNone/>
             </a:pPr>
             <a:r>
-              <a:rPr lang="en-US" sz="1100" b="1" dirty="0">
+              <a:rPr lang="en-US" sz="1000" b="1" dirty="0">
                 <a:solidFill>
                   <a:srgbClr val="111111"/>
                 </a:solidFill>
@@ -22360,7 +22404,7 @@
               </a:rPr>
               <a:t>VIP来店の把握</a:t>
             </a:r>
-            <a:endParaRPr lang="en-US" sz="1100" dirty="0"/>
+            <a:endParaRPr lang="en-US" sz="1000" dirty="0"/>
           </a:p>
         </p:txBody>
       </p:sp>
@@ -22394,8 +22438,8 @@
         </p:nvSpPr>
         <p:spPr>
           <a:xfrm>
-            <a:off x="5272888" y="5495544"/>
-            <a:ext cx="1645920" cy="411480"/>
+            <a:off x="5245456" y="5495544"/>
+            <a:ext cx="1737360" cy="411480"/>
           </a:xfrm>
           <a:prstGeom prst="rect">
             <a:avLst/>
@@ -22411,7 +22455,7 @@
               <a:buNone/>
             </a:pPr>
             <a:r>
-              <a:rPr lang="en-US" sz="1100" b="1" dirty="0">
+              <a:rPr lang="en-US" sz="1000" b="1" dirty="0">
                 <a:solidFill>
                   <a:srgbClr val="111111"/>
                 </a:solidFill>
@@ -22421,7 +22465,7 @@
               </a:rPr>
               <a:t>催事の効果測定</a:t>
             </a:r>
-            <a:endParaRPr lang="en-US" sz="1100" dirty="0"/>
+            <a:endParaRPr lang="en-US" sz="1000" dirty="0"/>
           </a:p>
         </p:txBody>
       </p:sp>
@@ -22579,8 +22623,8 @@
         </p:nvSpPr>
         <p:spPr>
           <a:xfrm>
-            <a:off x="7558888" y="4434840"/>
-            <a:ext cx="1645920" cy="411480"/>
+            <a:off x="7531456" y="4434840"/>
+            <a:ext cx="1737360" cy="411480"/>
           </a:xfrm>
           <a:prstGeom prst="rect">
             <a:avLst/>
@@ -22596,7 +22640,7 @@
               <a:buNone/>
             </a:pPr>
             <a:r>
-              <a:rPr lang="en-US" sz="1100" b="1" dirty="0">
+              <a:rPr lang="en-US" sz="1000" b="1" dirty="0">
                 <a:solidFill>
                   <a:srgbClr val="111111"/>
                 </a:solidFill>
@@ -22606,7 +22650,7 @@
               </a:rPr>
               <a:t>転倒の早期発見</a:t>
             </a:r>
-            <a:endParaRPr lang="en-US" sz="1100" dirty="0"/>
+            <a:endParaRPr lang="en-US" sz="1000" dirty="0"/>
           </a:p>
         </p:txBody>
       </p:sp>
@@ -22640,8 +22684,8 @@
         </p:nvSpPr>
         <p:spPr>
           <a:xfrm>
-            <a:off x="7558888" y="4965192"/>
-            <a:ext cx="1645920" cy="411480"/>
+            <a:off x="7531456" y="4965192"/>
+            <a:ext cx="1737360" cy="411480"/>
           </a:xfrm>
           <a:prstGeom prst="rect">
             <a:avLst/>
@@ -22657,7 +22701,7 @@
               <a:buNone/>
             </a:pPr>
             <a:r>
-              <a:rPr lang="en-US" sz="1100" b="1" dirty="0">
+              <a:rPr lang="en-US" sz="1000" b="1" dirty="0">
                 <a:solidFill>
                   <a:srgbClr val="111111"/>
                 </a:solidFill>
@@ -22667,7 +22711,7 @@
               </a:rPr>
               <a:t>侵入・徘徊の検知</a:t>
             </a:r>
-            <a:endParaRPr lang="en-US" sz="1100" dirty="0"/>
+            <a:endParaRPr lang="en-US" sz="1000" dirty="0"/>
           </a:p>
         </p:txBody>
       </p:sp>
@@ -22701,8 +22745,8 @@
         </p:nvSpPr>
         <p:spPr>
           <a:xfrm>
-            <a:off x="7558888" y="5495544"/>
-            <a:ext cx="1645920" cy="411480"/>
+            <a:off x="7531456" y="5495544"/>
+            <a:ext cx="1737360" cy="411480"/>
           </a:xfrm>
           <a:prstGeom prst="rect">
             <a:avLst/>
@@ -22718,7 +22762,7 @@
               <a:buNone/>
             </a:pPr>
             <a:r>
-              <a:rPr lang="en-US" sz="1100" b="1" dirty="0">
+              <a:rPr lang="en-US" sz="1000" b="1" dirty="0">
                 <a:solidFill>
                   <a:srgbClr val="111111"/>
                 </a:solidFill>
@@ -22728,7 +22772,7 @@
               </a:rPr>
               <a:t>夜間の見守り負担軽減</a:t>
             </a:r>
-            <a:endParaRPr lang="en-US" sz="1100" dirty="0"/>
+            <a:endParaRPr lang="en-US" sz="1000" dirty="0"/>
           </a:p>
         </p:txBody>
       </p:sp>
@@ -22886,8 +22930,8 @@
         </p:nvSpPr>
         <p:spPr>
           <a:xfrm>
-            <a:off x="9844888" y="4434840"/>
-            <a:ext cx="1645920" cy="411480"/>
+            <a:off x="9817456" y="4434840"/>
+            <a:ext cx="1737360" cy="411480"/>
           </a:xfrm>
           <a:prstGeom prst="rect">
             <a:avLst/>
@@ -22903,7 +22947,7 @@
               <a:buNone/>
             </a:pPr>
             <a:r>
-              <a:rPr lang="en-US" sz="1100" b="1" dirty="0">
+              <a:rPr lang="en-US" sz="1000" b="1" dirty="0">
                 <a:solidFill>
                   <a:srgbClr val="111111"/>
                 </a:solidFill>
@@ -22913,7 +22957,7 @@
               </a:rPr>
               <a:t>ATM前の通話・滞留検知</a:t>
             </a:r>
-            <a:endParaRPr lang="en-US" sz="1100" dirty="0"/>
+            <a:endParaRPr lang="en-US" sz="1000" dirty="0"/>
           </a:p>
         </p:txBody>
       </p:sp>
@@ -22947,8 +22991,8 @@
         </p:nvSpPr>
         <p:spPr>
           <a:xfrm>
-            <a:off x="9844888" y="4965192"/>
-            <a:ext cx="1645920" cy="411480"/>
+            <a:off x="9817456" y="4965192"/>
+            <a:ext cx="1737360" cy="411480"/>
           </a:xfrm>
           <a:prstGeom prst="rect">
             <a:avLst/>
@@ -22964,7 +23008,7 @@
               <a:buNone/>
             </a:pPr>
             <a:r>
-              <a:rPr lang="en-US" sz="1100" b="1" dirty="0">
+              <a:rPr lang="en-US" sz="1000" b="1" dirty="0">
                 <a:solidFill>
                   <a:srgbClr val="111111"/>
                 </a:solidFill>
@@ -22974,7 +23018,7 @@
               </a:rPr>
               <a:t>不審行動の把握</a:t>
             </a:r>
-            <a:endParaRPr lang="en-US" sz="1100" dirty="0"/>
+            <a:endParaRPr lang="en-US" sz="1000" dirty="0"/>
           </a:p>
         </p:txBody>
       </p:sp>
@@ -23008,8 +23052,8 @@
         </p:nvSpPr>
         <p:spPr>
           <a:xfrm>
-            <a:off x="9844888" y="5495544"/>
-            <a:ext cx="1645920" cy="411480"/>
+            <a:off x="9817456" y="5495544"/>
+            <a:ext cx="1737360" cy="411480"/>
           </a:xfrm>
           <a:prstGeom prst="rect">
             <a:avLst/>
@@ -23025,7 +23069,7 @@
               <a:buNone/>
             </a:pPr>
             <a:r>
-              <a:rPr lang="en-US" sz="1100" b="1" dirty="0">
+              <a:rPr lang="en-US" sz="1000" b="1" dirty="0">
                 <a:solidFill>
                   <a:srgbClr val="111111"/>
                 </a:solidFill>
@@ -23035,7 +23079,7 @@
               </a:rPr>
               <a:t>転倒時のフォロー</a:t>
             </a:r>
-            <a:endParaRPr lang="en-US" sz="1100" dirty="0"/>
+            <a:endParaRPr lang="en-US" sz="1000" dirty="0"/>
           </a:p>
         </p:txBody>
       </p:sp>

</xml_diff>